<commit_message>
improve the efficiency to be closer to freqpure, test the function on cifar10 & coco.
</commit_message>
<xml_diff>
--- a/week25-26.pptx
+++ b/week25-26.pptx
@@ -8,6 +8,9 @@
     <p:sldId id="256" r:id="rId2"/>
     <p:sldId id="257" r:id="rId3"/>
     <p:sldId id="258" r:id="rId4"/>
+    <p:sldId id="259" r:id="rId5"/>
+    <p:sldId id="260" r:id="rId6"/>
+    <p:sldId id="261" r:id="rId7"/>
   </p:sldIdLst>
   <p:sldSz cx="12192000" cy="6858000"/>
   <p:notesSz cx="6858000" cy="9144000"/>
@@ -261,7 +264,7 @@
           <a:p>
             <a:fld id="{A088158D-1440-40B9-9F6A-7CDE5D5CFC6D}" type="datetimeFigureOut">
               <a:rPr lang="zh-CN" altLang="en-US" smtClean="0"/>
-              <a:t>2026/9/28</a:t>
+              <a:t>2026/10/4</a:t>
             </a:fld>
             <a:endParaRPr lang="zh-CN" altLang="en-US"/>
           </a:p>
@@ -459,7 +462,7 @@
           <a:p>
             <a:fld id="{A088158D-1440-40B9-9F6A-7CDE5D5CFC6D}" type="datetimeFigureOut">
               <a:rPr lang="zh-CN" altLang="en-US" smtClean="0"/>
-              <a:t>2026/9/28</a:t>
+              <a:t>2026/10/4</a:t>
             </a:fld>
             <a:endParaRPr lang="zh-CN" altLang="en-US"/>
           </a:p>
@@ -667,7 +670,7 @@
           <a:p>
             <a:fld id="{A088158D-1440-40B9-9F6A-7CDE5D5CFC6D}" type="datetimeFigureOut">
               <a:rPr lang="zh-CN" altLang="en-US" smtClean="0"/>
-              <a:t>2026/9/28</a:t>
+              <a:t>2026/10/4</a:t>
             </a:fld>
             <a:endParaRPr lang="zh-CN" altLang="en-US"/>
           </a:p>
@@ -865,7 +868,7 @@
           <a:p>
             <a:fld id="{A088158D-1440-40B9-9F6A-7CDE5D5CFC6D}" type="datetimeFigureOut">
               <a:rPr lang="zh-CN" altLang="en-US" smtClean="0"/>
-              <a:t>2026/9/28</a:t>
+              <a:t>2026/10/4</a:t>
             </a:fld>
             <a:endParaRPr lang="zh-CN" altLang="en-US"/>
           </a:p>
@@ -1140,7 +1143,7 @@
           <a:p>
             <a:fld id="{A088158D-1440-40B9-9F6A-7CDE5D5CFC6D}" type="datetimeFigureOut">
               <a:rPr lang="zh-CN" altLang="en-US" smtClean="0"/>
-              <a:t>2026/9/28</a:t>
+              <a:t>2026/10/4</a:t>
             </a:fld>
             <a:endParaRPr lang="zh-CN" altLang="en-US"/>
           </a:p>
@@ -1405,7 +1408,7 @@
           <a:p>
             <a:fld id="{A088158D-1440-40B9-9F6A-7CDE5D5CFC6D}" type="datetimeFigureOut">
               <a:rPr lang="zh-CN" altLang="en-US" smtClean="0"/>
-              <a:t>2026/9/28</a:t>
+              <a:t>2026/10/4</a:t>
             </a:fld>
             <a:endParaRPr lang="zh-CN" altLang="en-US"/>
           </a:p>
@@ -1817,7 +1820,7 @@
           <a:p>
             <a:fld id="{A088158D-1440-40B9-9F6A-7CDE5D5CFC6D}" type="datetimeFigureOut">
               <a:rPr lang="zh-CN" altLang="en-US" smtClean="0"/>
-              <a:t>2026/9/28</a:t>
+              <a:t>2026/10/4</a:t>
             </a:fld>
             <a:endParaRPr lang="zh-CN" altLang="en-US"/>
           </a:p>
@@ -1958,7 +1961,7 @@
           <a:p>
             <a:fld id="{A088158D-1440-40B9-9F6A-7CDE5D5CFC6D}" type="datetimeFigureOut">
               <a:rPr lang="zh-CN" altLang="en-US" smtClean="0"/>
-              <a:t>2026/9/28</a:t>
+              <a:t>2026/10/4</a:t>
             </a:fld>
             <a:endParaRPr lang="zh-CN" altLang="en-US"/>
           </a:p>
@@ -2071,7 +2074,7 @@
           <a:p>
             <a:fld id="{A088158D-1440-40B9-9F6A-7CDE5D5CFC6D}" type="datetimeFigureOut">
               <a:rPr lang="zh-CN" altLang="en-US" smtClean="0"/>
-              <a:t>2026/9/28</a:t>
+              <a:t>2026/10/4</a:t>
             </a:fld>
             <a:endParaRPr lang="zh-CN" altLang="en-US"/>
           </a:p>
@@ -2382,7 +2385,7 @@
           <a:p>
             <a:fld id="{A088158D-1440-40B9-9F6A-7CDE5D5CFC6D}" type="datetimeFigureOut">
               <a:rPr lang="zh-CN" altLang="en-US" smtClean="0"/>
-              <a:t>2026/9/28</a:t>
+              <a:t>2026/10/4</a:t>
             </a:fld>
             <a:endParaRPr lang="zh-CN" altLang="en-US"/>
           </a:p>
@@ -2670,7 +2673,7 @@
           <a:p>
             <a:fld id="{A088158D-1440-40B9-9F6A-7CDE5D5CFC6D}" type="datetimeFigureOut">
               <a:rPr lang="zh-CN" altLang="en-US" smtClean="0"/>
-              <a:t>2026/9/28</a:t>
+              <a:t>2026/10/4</a:t>
             </a:fld>
             <a:endParaRPr lang="zh-CN" altLang="en-US"/>
           </a:p>
@@ -2911,7 +2914,7 @@
           <a:p>
             <a:fld id="{A088158D-1440-40B9-9F6A-7CDE5D5CFC6D}" type="datetimeFigureOut">
               <a:rPr lang="zh-CN" altLang="en-US" smtClean="0"/>
-              <a:t>2026/9/28</a:t>
+              <a:t>2026/10/4</a:t>
             </a:fld>
             <a:endParaRPr lang="zh-CN" altLang="en-US"/>
           </a:p>
@@ -4475,6 +4478,1285 @@
 </p:sld>
 </file>
 
+<file path=ppt/slides/slide4.xml><?xml version="1.0" encoding="utf-8"?>
+<p:sld xmlns:a="http://schemas.openxmlformats.org/drawingml/2006/main" xmlns:r="http://schemas.openxmlformats.org/officeDocument/2006/relationships" xmlns:p="http://schemas.openxmlformats.org/presentationml/2006/main">
+  <p:cSld>
+    <p:spTree>
+      <p:nvGrpSpPr>
+        <p:cNvPr id="1" name=""/>
+        <p:cNvGrpSpPr/>
+        <p:nvPr/>
+      </p:nvGrpSpPr>
+      <p:grpSpPr>
+        <a:xfrm>
+          <a:off x="0" y="0"/>
+          <a:ext cx="0" cy="0"/>
+          <a:chOff x="0" y="0"/>
+          <a:chExt cx="0" cy="0"/>
+        </a:xfrm>
+      </p:grpSpPr>
+      <p:sp>
+        <p:nvSpPr>
+          <p:cNvPr id="2" name="标题 1">
+            <a:extLst>
+              <a:ext uri="{FF2B5EF4-FFF2-40B4-BE49-F238E27FC236}">
+                <a16:creationId xmlns:a16="http://schemas.microsoft.com/office/drawing/2014/main" id="{9FE4CBD5-EE75-4F72-D623-89D9C79F0467}"/>
+              </a:ext>
+            </a:extLst>
+          </p:cNvPr>
+          <p:cNvSpPr>
+            <a:spLocks noGrp="1"/>
+          </p:cNvSpPr>
+          <p:nvPr>
+            <p:ph type="title"/>
+          </p:nvPr>
+        </p:nvSpPr>
+        <p:spPr/>
+        <p:txBody>
+          <a:bodyPr/>
+          <a:lstStyle/>
+          <a:p>
+            <a:r>
+              <a:rPr lang="zh-CN" altLang="zh-CN" dirty="0"/>
+              <a:t>High-Frequency-Aware GCN-Skip Binary Autoencoder（HF-AE</a:t>
+            </a:r>
+            <a:r>
+              <a:rPr lang="zh-CN" altLang="en-US" dirty="0"/>
+              <a:t>）</a:t>
+            </a:r>
+          </a:p>
+        </p:txBody>
+      </p:sp>
+      <p:sp>
+        <p:nvSpPr>
+          <p:cNvPr id="3" name="内容占位符 2">
+            <a:extLst>
+              <a:ext uri="{FF2B5EF4-FFF2-40B4-BE49-F238E27FC236}">
+                <a16:creationId xmlns:a16="http://schemas.microsoft.com/office/drawing/2014/main" id="{006A4C91-D631-1B48-E153-7B2BA5806361}"/>
+              </a:ext>
+            </a:extLst>
+          </p:cNvPr>
+          <p:cNvSpPr>
+            <a:spLocks noGrp="1"/>
+          </p:cNvSpPr>
+          <p:nvPr>
+            <p:ph idx="1"/>
+          </p:nvPr>
+        </p:nvSpPr>
+        <p:spPr/>
+        <p:txBody>
+          <a:bodyPr>
+            <a:normAutofit fontScale="92500" lnSpcReduction="20000"/>
+          </a:bodyPr>
+          <a:lstStyle/>
+          <a:p>
+            <a:r>
+              <a:rPr lang="zh-CN" altLang="en-US" sz="1800" dirty="0"/>
+              <a:t>新增多尺度高通损失，</a:t>
+            </a:r>
+            <a:r>
+              <a:rPr lang="zh-CN" altLang="zh-CN" sz="1800" dirty="0"/>
+              <a:t>让模型保留：</a:t>
+            </a:r>
+          </a:p>
+          <a:p>
+            <a:pPr lvl="0"/>
+            <a:r>
+              <a:rPr lang="zh-CN" altLang="zh-CN" sz="1800" dirty="0"/>
+              <a:t>火焰边缘</a:t>
+            </a:r>
+          </a:p>
+          <a:p>
+            <a:pPr lvl="0"/>
+            <a:r>
+              <a:rPr lang="zh-CN" altLang="zh-CN" sz="1800" dirty="0"/>
+              <a:t>烟雾轮廓</a:t>
+            </a:r>
+          </a:p>
+          <a:p>
+            <a:pPr lvl="0"/>
+            <a:r>
+              <a:rPr lang="zh-CN" altLang="zh-CN" sz="1800" dirty="0"/>
+              <a:t>局部纹理</a:t>
+            </a:r>
+          </a:p>
+          <a:p>
+            <a:pPr lvl="0"/>
+            <a:r>
+              <a:rPr lang="zh-CN" altLang="zh-CN" sz="1800" dirty="0"/>
+              <a:t>小目标结构</a:t>
+            </a:r>
+            <a:endParaRPr lang="en-US" altLang="zh-CN" sz="1800" dirty="0"/>
+          </a:p>
+          <a:p>
+            <a:pPr lvl="0"/>
+            <a:r>
+              <a:rPr lang="zh-CN" altLang="en-US" sz="1800" dirty="0"/>
+              <a:t>新增</a:t>
+            </a:r>
+            <a:r>
+              <a:rPr lang="en-US" altLang="zh-CN" sz="1800" dirty="0"/>
+              <a:t>FFT</a:t>
+            </a:r>
+            <a:r>
+              <a:rPr lang="zh-CN" altLang="en-US" sz="1800" dirty="0"/>
+              <a:t>高频幅度损失</a:t>
+            </a:r>
+            <a:endParaRPr lang="en-US" altLang="zh-CN" sz="1800" dirty="0"/>
+          </a:p>
+          <a:p>
+            <a:pPr lvl="0"/>
+            <a:endParaRPr lang="zh-CN" altLang="zh-CN" sz="1800" dirty="0"/>
+          </a:p>
+          <a:p>
+            <a:r>
+              <a:rPr lang="zh-CN" altLang="zh-CN" sz="1900" dirty="0"/>
+              <a:t>相比 Learned-v2：</a:t>
+            </a:r>
+          </a:p>
+          <a:p>
+            <a:pPr lvl="0"/>
+            <a:r>
+              <a:rPr lang="zh-CN" altLang="zh-CN" sz="1900" dirty="0"/>
+              <a:t>中频能量比：0.2062 → 0.3667</a:t>
+            </a:r>
+          </a:p>
+          <a:p>
+            <a:pPr lvl="0"/>
+            <a:r>
+              <a:rPr lang="zh-CN" altLang="zh-CN" sz="1900" dirty="0"/>
+              <a:t>中频幅度误差：0.8187 → 0.6063</a:t>
+            </a:r>
+          </a:p>
+          <a:p>
+            <a:pPr lvl="0"/>
+            <a:r>
+              <a:rPr lang="zh-CN" altLang="zh-CN" sz="1900" dirty="0"/>
+              <a:t>高频能量比：0.1414 → 0.1651</a:t>
+            </a:r>
+          </a:p>
+          <a:p>
+            <a:pPr lvl="0"/>
+            <a:r>
+              <a:rPr lang="zh-CN" altLang="zh-CN" sz="1900" dirty="0"/>
+              <a:t>高频幅度误差：0.9053 → 0.8369</a:t>
+            </a:r>
+          </a:p>
+          <a:p>
+            <a:pPr lvl="0"/>
+            <a:r>
+              <a:rPr lang="zh-CN" altLang="zh-CN" sz="1900" dirty="0"/>
+              <a:t>低频幅度误差也从 0.3628 降到 0.3266</a:t>
+            </a:r>
+          </a:p>
+          <a:p>
+            <a:endParaRPr lang="zh-CN" altLang="en-US" dirty="0"/>
+          </a:p>
+        </p:txBody>
+      </p:sp>
+    </p:spTree>
+    <p:extLst>
+      <p:ext uri="{BB962C8B-B14F-4D97-AF65-F5344CB8AC3E}">
+        <p14:creationId xmlns:p14="http://schemas.microsoft.com/office/powerpoint/2010/main" val="3235583982"/>
+      </p:ext>
+    </p:extLst>
+  </p:cSld>
+  <p:clrMapOvr>
+    <a:masterClrMapping/>
+  </p:clrMapOvr>
+</p:sld>
+</file>
+
+<file path=ppt/slides/slide5.xml><?xml version="1.0" encoding="utf-8"?>
+<p:sld xmlns:a="http://schemas.openxmlformats.org/drawingml/2006/main" xmlns:r="http://schemas.openxmlformats.org/officeDocument/2006/relationships" xmlns:p="http://schemas.openxmlformats.org/presentationml/2006/main">
+  <p:cSld>
+    <p:spTree>
+      <p:nvGrpSpPr>
+        <p:cNvPr id="1" name=""/>
+        <p:cNvGrpSpPr/>
+        <p:nvPr/>
+      </p:nvGrpSpPr>
+      <p:grpSpPr>
+        <a:xfrm>
+          <a:off x="0" y="0"/>
+          <a:ext cx="0" cy="0"/>
+          <a:chOff x="0" y="0"/>
+          <a:chExt cx="0" cy="0"/>
+        </a:xfrm>
+      </p:grpSpPr>
+      <p:sp>
+        <p:nvSpPr>
+          <p:cNvPr id="2" name="标题 1">
+            <a:extLst>
+              <a:ext uri="{FF2B5EF4-FFF2-40B4-BE49-F238E27FC236}">
+                <a16:creationId xmlns:a16="http://schemas.microsoft.com/office/drawing/2014/main" id="{EB277C22-C832-0C75-5FAF-4AA1EAE27832}"/>
+              </a:ext>
+            </a:extLst>
+          </p:cNvPr>
+          <p:cNvSpPr>
+            <a:spLocks noGrp="1"/>
+          </p:cNvSpPr>
+          <p:nvPr>
+            <p:ph type="title"/>
+          </p:nvPr>
+        </p:nvSpPr>
+        <p:spPr/>
+        <p:txBody>
+          <a:bodyPr/>
+          <a:lstStyle/>
+          <a:p>
+            <a:endParaRPr lang="zh-CN" altLang="en-US" dirty="0"/>
+          </a:p>
+        </p:txBody>
+      </p:sp>
+      <p:graphicFrame>
+        <p:nvGraphicFramePr>
+          <p:cNvPr id="4" name="内容占位符 3">
+            <a:extLst>
+              <a:ext uri="{FF2B5EF4-FFF2-40B4-BE49-F238E27FC236}">
+                <a16:creationId xmlns:a16="http://schemas.microsoft.com/office/drawing/2014/main" id="{A6B5E40C-79DD-C943-16C8-AE4017606862}"/>
+              </a:ext>
+            </a:extLst>
+          </p:cNvPr>
+          <p:cNvGraphicFramePr>
+            <a:graphicFrameLocks noGrp="1"/>
+          </p:cNvGraphicFramePr>
+          <p:nvPr>
+            <p:ph idx="1"/>
+            <p:extLst>
+              <p:ext uri="{D42A27DB-BD31-4B8C-83A1-F6EECF244321}">
+                <p14:modId xmlns:p14="http://schemas.microsoft.com/office/powerpoint/2010/main" val="4183693469"/>
+              </p:ext>
+            </p:extLst>
+          </p:nvPr>
+        </p:nvGraphicFramePr>
+        <p:xfrm>
+          <a:off x="838200" y="365125"/>
+          <a:ext cx="10515600" cy="2468880"/>
+        </p:xfrm>
+        <a:graphic>
+          <a:graphicData uri="http://schemas.openxmlformats.org/drawingml/2006/table">
+            <a:tbl>
+              <a:tblPr>
+                <a:tableStyleId>{5C22544A-7EE6-4342-B048-85BDC9FD1C3A}</a:tableStyleId>
+              </a:tblPr>
+              <a:tblGrid>
+                <a:gridCol w="2628900">
+                  <a:extLst>
+                    <a:ext uri="{9D8B030D-6E8A-4147-A177-3AD203B41FA5}">
+                      <a16:colId xmlns:a16="http://schemas.microsoft.com/office/drawing/2014/main" val="442829487"/>
+                    </a:ext>
+                  </a:extLst>
+                </a:gridCol>
+                <a:gridCol w="2628900">
+                  <a:extLst>
+                    <a:ext uri="{9D8B030D-6E8A-4147-A177-3AD203B41FA5}">
+                      <a16:colId xmlns:a16="http://schemas.microsoft.com/office/drawing/2014/main" val="1059025715"/>
+                    </a:ext>
+                  </a:extLst>
+                </a:gridCol>
+                <a:gridCol w="2628900">
+                  <a:extLst>
+                    <a:ext uri="{9D8B030D-6E8A-4147-A177-3AD203B41FA5}">
+                      <a16:colId xmlns:a16="http://schemas.microsoft.com/office/drawing/2014/main" val="2104522932"/>
+                    </a:ext>
+                  </a:extLst>
+                </a:gridCol>
+                <a:gridCol w="2628900">
+                  <a:extLst>
+                    <a:ext uri="{9D8B030D-6E8A-4147-A177-3AD203B41FA5}">
+                      <a16:colId xmlns:a16="http://schemas.microsoft.com/office/drawing/2014/main" val="1171266255"/>
+                    </a:ext>
+                  </a:extLst>
+                </a:gridCol>
+              </a:tblGrid>
+              <a:tr h="0">
+                <a:tc>
+                  <a:txBody>
+                    <a:bodyPr/>
+                    <a:lstStyle/>
+                    <a:p>
+                      <a:pPr>
+                        <a:buNone/>
+                      </a:pPr>
+                      <a:r>
+                        <a:rPr lang="zh-CN"/>
+                        <a:t>指标</a:t>
+                      </a:r>
+                    </a:p>
+                  </a:txBody>
+                  <a:tcPr anchor="ctr"/>
+                </a:tc>
+                <a:tc>
+                  <a:txBody>
+                    <a:bodyPr/>
+                    <a:lstStyle/>
+                    <a:p>
+                      <a:pPr>
+                        <a:buNone/>
+                      </a:pPr>
+                      <a:r>
+                        <a:rPr lang="zh-CN"/>
+                        <a:t>Learned-v2</a:t>
+                      </a:r>
+                    </a:p>
+                  </a:txBody>
+                  <a:tcPr anchor="ctr"/>
+                </a:tc>
+                <a:tc>
+                  <a:txBody>
+                    <a:bodyPr/>
+                    <a:lstStyle/>
+                    <a:p>
+                      <a:pPr>
+                        <a:buNone/>
+                      </a:pPr>
+                      <a:r>
+                        <a:rPr lang="zh-CN"/>
+                        <a:t>HF-AE</a:t>
+                      </a:r>
+                    </a:p>
+                  </a:txBody>
+                  <a:tcPr anchor="ctr"/>
+                </a:tc>
+                <a:tc>
+                  <a:txBody>
+                    <a:bodyPr/>
+                    <a:lstStyle/>
+                    <a:p>
+                      <a:pPr>
+                        <a:buNone/>
+                      </a:pPr>
+                      <a:r>
+                        <a:rPr lang="zh-CN"/>
+                        <a:t>提升</a:t>
+                      </a:r>
+                    </a:p>
+                  </a:txBody>
+                  <a:tcPr anchor="ctr"/>
+                </a:tc>
+                <a:extLst>
+                  <a:ext uri="{0D108BD9-81ED-4DB2-BD59-A6C34878D82A}">
+                    <a16:rowId xmlns:a16="http://schemas.microsoft.com/office/drawing/2014/main" val="3862019471"/>
+                  </a:ext>
+                </a:extLst>
+              </a:tr>
+              <a:tr h="0">
+                <a:tc>
+                  <a:txBody>
+                    <a:bodyPr/>
+                    <a:lstStyle/>
+                    <a:p>
+                      <a:pPr>
+                        <a:buNone/>
+                      </a:pPr>
+                      <a:r>
+                        <a:rPr lang="zh-CN"/>
+                        <a:t>clean reconstructed mAP50</a:t>
+                      </a:r>
+                    </a:p>
+                  </a:txBody>
+                  <a:tcPr anchor="ctr"/>
+                </a:tc>
+                <a:tc>
+                  <a:txBody>
+                    <a:bodyPr/>
+                    <a:lstStyle/>
+                    <a:p>
+                      <a:pPr>
+                        <a:buNone/>
+                      </a:pPr>
+                      <a:r>
+                        <a:rPr lang="zh-CN"/>
+                        <a:t>0.3762</a:t>
+                      </a:r>
+                    </a:p>
+                  </a:txBody>
+                  <a:tcPr anchor="ctr"/>
+                </a:tc>
+                <a:tc>
+                  <a:txBody>
+                    <a:bodyPr/>
+                    <a:lstStyle/>
+                    <a:p>
+                      <a:pPr>
+                        <a:buNone/>
+                      </a:pPr>
+                      <a:r>
+                        <a:rPr lang="zh-CN"/>
+                        <a:t>0.4070</a:t>
+                      </a:r>
+                    </a:p>
+                  </a:txBody>
+                  <a:tcPr anchor="ctr"/>
+                </a:tc>
+                <a:tc>
+                  <a:txBody>
+                    <a:bodyPr/>
+                    <a:lstStyle/>
+                    <a:p>
+                      <a:pPr>
+                        <a:buNone/>
+                      </a:pPr>
+                      <a:r>
+                        <a:rPr lang="zh-CN"/>
+                        <a:t>+0.0308</a:t>
+                      </a:r>
+                    </a:p>
+                  </a:txBody>
+                  <a:tcPr anchor="ctr"/>
+                </a:tc>
+                <a:extLst>
+                  <a:ext uri="{0D108BD9-81ED-4DB2-BD59-A6C34878D82A}">
+                    <a16:rowId xmlns:a16="http://schemas.microsoft.com/office/drawing/2014/main" val="3335013604"/>
+                  </a:ext>
+                </a:extLst>
+              </a:tr>
+              <a:tr h="0">
+                <a:tc>
+                  <a:txBody>
+                    <a:bodyPr/>
+                    <a:lstStyle/>
+                    <a:p>
+                      <a:pPr>
+                        <a:buNone/>
+                      </a:pPr>
+                      <a:r>
+                        <a:rPr lang="zh-CN"/>
+                        <a:t>PGD direct mAP50</a:t>
+                      </a:r>
+                    </a:p>
+                  </a:txBody>
+                  <a:tcPr anchor="ctr"/>
+                </a:tc>
+                <a:tc>
+                  <a:txBody>
+                    <a:bodyPr/>
+                    <a:lstStyle/>
+                    <a:p>
+                      <a:pPr>
+                        <a:buNone/>
+                      </a:pPr>
+                      <a:r>
+                        <a:rPr lang="zh-CN"/>
+                        <a:t>0.3716</a:t>
+                      </a:r>
+                    </a:p>
+                  </a:txBody>
+                  <a:tcPr anchor="ctr"/>
+                </a:tc>
+                <a:tc>
+                  <a:txBody>
+                    <a:bodyPr/>
+                    <a:lstStyle/>
+                    <a:p>
+                      <a:pPr>
+                        <a:buNone/>
+                      </a:pPr>
+                      <a:r>
+                        <a:rPr lang="zh-CN"/>
+                        <a:t>0.4021</a:t>
+                      </a:r>
+                    </a:p>
+                  </a:txBody>
+                  <a:tcPr anchor="ctr"/>
+                </a:tc>
+                <a:tc>
+                  <a:txBody>
+                    <a:bodyPr/>
+                    <a:lstStyle/>
+                    <a:p>
+                      <a:pPr>
+                        <a:buNone/>
+                      </a:pPr>
+                      <a:r>
+                        <a:rPr lang="zh-CN"/>
+                        <a:t>+0.0305</a:t>
+                      </a:r>
+                    </a:p>
+                  </a:txBody>
+                  <a:tcPr anchor="ctr"/>
+                </a:tc>
+                <a:extLst>
+                  <a:ext uri="{0D108BD9-81ED-4DB2-BD59-A6C34878D82A}">
+                    <a16:rowId xmlns:a16="http://schemas.microsoft.com/office/drawing/2014/main" val="567092944"/>
+                  </a:ext>
+                </a:extLst>
+              </a:tr>
+              <a:tr h="0">
+                <a:tc>
+                  <a:txBody>
+                    <a:bodyPr/>
+                    <a:lstStyle/>
+                    <a:p>
+                      <a:pPr>
+                        <a:buNone/>
+                      </a:pPr>
+                      <a:r>
+                        <a:rPr lang="zh-CN"/>
+                        <a:t>clean mAP50-95</a:t>
+                      </a:r>
+                    </a:p>
+                  </a:txBody>
+                  <a:tcPr anchor="ctr"/>
+                </a:tc>
+                <a:tc>
+                  <a:txBody>
+                    <a:bodyPr/>
+                    <a:lstStyle/>
+                    <a:p>
+                      <a:pPr>
+                        <a:buNone/>
+                      </a:pPr>
+                      <a:r>
+                        <a:rPr lang="zh-CN"/>
+                        <a:t>0.1793</a:t>
+                      </a:r>
+                    </a:p>
+                  </a:txBody>
+                  <a:tcPr anchor="ctr"/>
+                </a:tc>
+                <a:tc>
+                  <a:txBody>
+                    <a:bodyPr/>
+                    <a:lstStyle/>
+                    <a:p>
+                      <a:pPr>
+                        <a:buNone/>
+                      </a:pPr>
+                      <a:r>
+                        <a:rPr lang="zh-CN"/>
+                        <a:t>0.1980</a:t>
+                      </a:r>
+                    </a:p>
+                  </a:txBody>
+                  <a:tcPr anchor="ctr"/>
+                </a:tc>
+                <a:tc>
+                  <a:txBody>
+                    <a:bodyPr/>
+                    <a:lstStyle/>
+                    <a:p>
+                      <a:pPr>
+                        <a:buNone/>
+                      </a:pPr>
+                      <a:r>
+                        <a:rPr lang="zh-CN"/>
+                        <a:t>+0.0187</a:t>
+                      </a:r>
+                    </a:p>
+                  </a:txBody>
+                  <a:tcPr anchor="ctr"/>
+                </a:tc>
+                <a:extLst>
+                  <a:ext uri="{0D108BD9-81ED-4DB2-BD59-A6C34878D82A}">
+                    <a16:rowId xmlns:a16="http://schemas.microsoft.com/office/drawing/2014/main" val="753104860"/>
+                  </a:ext>
+                </a:extLst>
+              </a:tr>
+              <a:tr h="0">
+                <a:tc>
+                  <a:txBody>
+                    <a:bodyPr/>
+                    <a:lstStyle/>
+                    <a:p>
+                      <a:pPr>
+                        <a:buNone/>
+                      </a:pPr>
+                      <a:r>
+                        <a:rPr lang="zh-CN"/>
+                        <a:t>PGD direct mAP50-95</a:t>
+                      </a:r>
+                    </a:p>
+                  </a:txBody>
+                  <a:tcPr anchor="ctr"/>
+                </a:tc>
+                <a:tc>
+                  <a:txBody>
+                    <a:bodyPr/>
+                    <a:lstStyle/>
+                    <a:p>
+                      <a:pPr>
+                        <a:buNone/>
+                      </a:pPr>
+                      <a:r>
+                        <a:rPr lang="zh-CN"/>
+                        <a:t>0.1768</a:t>
+                      </a:r>
+                    </a:p>
+                  </a:txBody>
+                  <a:tcPr anchor="ctr"/>
+                </a:tc>
+                <a:tc>
+                  <a:txBody>
+                    <a:bodyPr/>
+                    <a:lstStyle/>
+                    <a:p>
+                      <a:pPr>
+                        <a:buNone/>
+                      </a:pPr>
+                      <a:r>
+                        <a:rPr lang="zh-CN"/>
+                        <a:t>0.1944</a:t>
+                      </a:r>
+                    </a:p>
+                  </a:txBody>
+                  <a:tcPr anchor="ctr"/>
+                </a:tc>
+                <a:tc>
+                  <a:txBody>
+                    <a:bodyPr/>
+                    <a:lstStyle/>
+                    <a:p>
+                      <a:pPr>
+                        <a:buNone/>
+                      </a:pPr>
+                      <a:r>
+                        <a:rPr lang="zh-CN"/>
+                        <a:t>+0.0176</a:t>
+                      </a:r>
+                    </a:p>
+                  </a:txBody>
+                  <a:tcPr anchor="ctr"/>
+                </a:tc>
+                <a:extLst>
+                  <a:ext uri="{0D108BD9-81ED-4DB2-BD59-A6C34878D82A}">
+                    <a16:rowId xmlns:a16="http://schemas.microsoft.com/office/drawing/2014/main" val="2151430518"/>
+                  </a:ext>
+                </a:extLst>
+              </a:tr>
+              <a:tr h="0">
+                <a:tc>
+                  <a:txBody>
+                    <a:bodyPr/>
+                    <a:lstStyle/>
+                    <a:p>
+                      <a:pPr>
+                        <a:buNone/>
+                      </a:pPr>
+                      <a:r>
+                        <a:rPr lang="zh-CN"/>
+                        <a:t>PGD恢复率</a:t>
+                      </a:r>
+                    </a:p>
+                  </a:txBody>
+                  <a:tcPr anchor="ctr"/>
+                </a:tc>
+                <a:tc>
+                  <a:txBody>
+                    <a:bodyPr/>
+                    <a:lstStyle/>
+                    <a:p>
+                      <a:pPr>
+                        <a:buNone/>
+                      </a:pPr>
+                      <a:r>
+                        <a:rPr lang="zh-CN"/>
+                        <a:t>64.5%</a:t>
+                      </a:r>
+                    </a:p>
+                  </a:txBody>
+                  <a:tcPr anchor="ctr"/>
+                </a:tc>
+                <a:tc>
+                  <a:txBody>
+                    <a:bodyPr/>
+                    <a:lstStyle/>
+                    <a:p>
+                      <a:pPr>
+                        <a:buNone/>
+                      </a:pPr>
+                      <a:r>
+                        <a:rPr lang="zh-CN"/>
+                        <a:t>69.8%</a:t>
+                      </a:r>
+                    </a:p>
+                  </a:txBody>
+                  <a:tcPr anchor="ctr"/>
+                </a:tc>
+                <a:tc>
+                  <a:txBody>
+                    <a:bodyPr/>
+                    <a:lstStyle/>
+                    <a:p>
+                      <a:pPr>
+                        <a:buNone/>
+                      </a:pPr>
+                      <a:r>
+                        <a:rPr lang="zh-CN" dirty="0"/>
+                        <a:t>+5.3个百分点</a:t>
+                      </a:r>
+                    </a:p>
+                  </a:txBody>
+                  <a:tcPr anchor="ctr"/>
+                </a:tc>
+                <a:extLst>
+                  <a:ext uri="{0D108BD9-81ED-4DB2-BD59-A6C34878D82A}">
+                    <a16:rowId xmlns:a16="http://schemas.microsoft.com/office/drawing/2014/main" val="77401468"/>
+                  </a:ext>
+                </a:extLst>
+              </a:tr>
+            </a:tbl>
+          </a:graphicData>
+        </a:graphic>
+      </p:graphicFrame>
+      <p:sp>
+        <p:nvSpPr>
+          <p:cNvPr id="6" name="文本框 5">
+            <a:extLst>
+              <a:ext uri="{FF2B5EF4-FFF2-40B4-BE49-F238E27FC236}">
+                <a16:creationId xmlns:a16="http://schemas.microsoft.com/office/drawing/2014/main" id="{9C8EB223-4566-4EB7-61AE-7BF40654523C}"/>
+              </a:ext>
+            </a:extLst>
+          </p:cNvPr>
+          <p:cNvSpPr txBox="1"/>
+          <p:nvPr/>
+        </p:nvSpPr>
+        <p:spPr>
+          <a:xfrm>
+            <a:off x="952500" y="3075525"/>
+            <a:ext cx="6096000" cy="2862322"/>
+          </a:xfrm>
+          <a:prstGeom prst="rect">
+            <a:avLst/>
+          </a:prstGeom>
+          <a:noFill/>
+        </p:spPr>
+        <p:txBody>
+          <a:bodyPr wrap="square">
+            <a:spAutoFit/>
+          </a:bodyPr>
+          <a:lstStyle/>
+          <a:p>
+            <a:pPr>
+              <a:buNone/>
+            </a:pPr>
+            <a:r>
+              <a:rPr lang="zh-CN" altLang="zh-CN" dirty="0"/>
+              <a:t>PGD 前后的编码差异率为：</a:t>
+            </a:r>
+          </a:p>
+          <a:p>
+            <a:pPr marL="342900" lvl="0" indent="-342900">
+              <a:buFont typeface="Arial" panose="020B0604020202020204" pitchFamily="34" charset="0"/>
+              <a:buChar char="•"/>
+            </a:pPr>
+            <a:r>
+              <a:rPr lang="zh-CN" altLang="zh-CN" dirty="0"/>
+              <a:t>main：</a:t>
+            </a:r>
+            <a:r>
+              <a:rPr lang="zh-CN" altLang="zh-CN" dirty="0">
+                <a:latin typeface="+mn-lt"/>
+              </a:rPr>
+              <a:t>0.3842%</a:t>
+            </a:r>
+            <a:endParaRPr lang="zh-CN" altLang="zh-CN" dirty="0"/>
+          </a:p>
+          <a:p>
+            <a:pPr marL="342900" lvl="0" indent="-342900">
+              <a:buFont typeface="Arial" panose="020B0604020202020204" pitchFamily="34" charset="0"/>
+              <a:buChar char="•"/>
+            </a:pPr>
+            <a:r>
+              <a:rPr lang="zh-CN" altLang="zh-CN" dirty="0"/>
+              <a:t>skip64：</a:t>
+            </a:r>
+            <a:r>
+              <a:rPr lang="zh-CN" altLang="zh-CN" dirty="0">
+                <a:latin typeface="+mn-lt"/>
+              </a:rPr>
+              <a:t>3.7184%</a:t>
+            </a:r>
+            <a:endParaRPr lang="zh-CN" altLang="zh-CN" dirty="0"/>
+          </a:p>
+          <a:p>
+            <a:pPr marL="342900" lvl="0" indent="-342900">
+              <a:buFont typeface="Arial" panose="020B0604020202020204" pitchFamily="34" charset="0"/>
+              <a:buChar char="•"/>
+            </a:pPr>
+            <a:r>
+              <a:rPr lang="zh-CN" altLang="zh-CN" dirty="0"/>
+              <a:t>skip32：</a:t>
+            </a:r>
+            <a:r>
+              <a:rPr lang="zh-CN" altLang="zh-CN" dirty="0">
+                <a:latin typeface="+mn-lt"/>
+              </a:rPr>
+              <a:t>2.6354%</a:t>
+            </a:r>
+            <a:endParaRPr lang="zh-CN" altLang="zh-CN" dirty="0"/>
+          </a:p>
+          <a:p>
+            <a:pPr>
+              <a:buNone/>
+            </a:pPr>
+            <a:r>
+              <a:rPr lang="zh-CN" altLang="zh-CN" dirty="0"/>
+              <a:t>虽然 skip 翻转更多，但旁路消融证明，真正影响检测的是 main：</a:t>
+            </a:r>
+          </a:p>
+          <a:p>
+            <a:pPr marL="342900" lvl="0" indent="-342900">
+              <a:buFont typeface="Arial" panose="020B0604020202020204" pitchFamily="34" charset="0"/>
+              <a:buChar char="•"/>
+            </a:pPr>
+            <a:r>
+              <a:rPr lang="zh-CN" altLang="zh-CN" dirty="0"/>
+              <a:t>全干净编码：</a:t>
+            </a:r>
+            <a:r>
+              <a:rPr lang="zh-CN" altLang="zh-CN" dirty="0">
+                <a:latin typeface="+mn-lt"/>
+              </a:rPr>
+              <a:t>0.4070</a:t>
+            </a:r>
+            <a:endParaRPr lang="zh-CN" altLang="zh-CN" dirty="0"/>
+          </a:p>
+          <a:p>
+            <a:pPr marL="342900" lvl="0" indent="-342900">
+              <a:buFont typeface="Arial" panose="020B0604020202020204" pitchFamily="34" charset="0"/>
+              <a:buChar char="•"/>
+            </a:pPr>
+            <a:r>
+              <a:rPr lang="zh-CN" altLang="zh-CN" dirty="0"/>
+              <a:t>只有 main 来自 PGD：</a:t>
+            </a:r>
+            <a:r>
+              <a:rPr lang="zh-CN" altLang="zh-CN" dirty="0">
+                <a:latin typeface="+mn-lt"/>
+              </a:rPr>
+              <a:t>0.4030</a:t>
+            </a:r>
+            <a:r>
+              <a:rPr lang="zh-CN" altLang="zh-CN" dirty="0"/>
+              <a:t>，下降 </a:t>
+            </a:r>
+            <a:r>
+              <a:rPr lang="zh-CN" altLang="zh-CN" dirty="0">
+                <a:latin typeface="+mn-lt"/>
+              </a:rPr>
+              <a:t>0.0040</a:t>
+            </a:r>
+            <a:endParaRPr lang="zh-CN" altLang="zh-CN" dirty="0"/>
+          </a:p>
+          <a:p>
+            <a:pPr marL="342900" lvl="0" indent="-342900">
+              <a:buFont typeface="Arial" panose="020B0604020202020204" pitchFamily="34" charset="0"/>
+              <a:buChar char="•"/>
+            </a:pPr>
+            <a:r>
+              <a:rPr lang="zh-CN" altLang="zh-CN" dirty="0"/>
+              <a:t>只有两个 skip 来自 PGD：</a:t>
+            </a:r>
+            <a:r>
+              <a:rPr lang="zh-CN" altLang="zh-CN" dirty="0">
+                <a:latin typeface="+mn-lt"/>
+              </a:rPr>
+              <a:t>0.4055</a:t>
+            </a:r>
+            <a:r>
+              <a:rPr lang="zh-CN" altLang="zh-CN" dirty="0"/>
+              <a:t>，只下降 </a:t>
+            </a:r>
+            <a:r>
+              <a:rPr lang="zh-CN" altLang="zh-CN" dirty="0">
+                <a:latin typeface="+mn-lt"/>
+              </a:rPr>
+              <a:t>0.0015</a:t>
+            </a:r>
+            <a:endParaRPr lang="zh-CN" altLang="zh-CN" dirty="0"/>
+          </a:p>
+          <a:p>
+            <a:pPr marL="342900" lvl="0" indent="-342900">
+              <a:buFont typeface="Arial" panose="020B0604020202020204" pitchFamily="34" charset="0"/>
+              <a:buChar char="•"/>
+            </a:pPr>
+            <a:r>
+              <a:rPr lang="zh-CN" altLang="zh-CN" dirty="0"/>
+              <a:t>单独污染 skip64 或 skip32：几乎没有影响</a:t>
+            </a:r>
+          </a:p>
+        </p:txBody>
+      </p:sp>
+    </p:spTree>
+    <p:extLst>
+      <p:ext uri="{BB962C8B-B14F-4D97-AF65-F5344CB8AC3E}">
+        <p14:creationId xmlns:p14="http://schemas.microsoft.com/office/powerpoint/2010/main" val="3566640485"/>
+      </p:ext>
+    </p:extLst>
+  </p:cSld>
+  <p:clrMapOvr>
+    <a:masterClrMapping/>
+  </p:clrMapOvr>
+</p:sld>
+</file>
+
+<file path=ppt/slides/slide6.xml><?xml version="1.0" encoding="utf-8"?>
+<p:sld xmlns:a="http://schemas.openxmlformats.org/drawingml/2006/main" xmlns:r="http://schemas.openxmlformats.org/officeDocument/2006/relationships" xmlns:p="http://schemas.openxmlformats.org/presentationml/2006/main">
+  <p:cSld>
+    <p:spTree>
+      <p:nvGrpSpPr>
+        <p:cNvPr id="1" name=""/>
+        <p:cNvGrpSpPr/>
+        <p:nvPr/>
+      </p:nvGrpSpPr>
+      <p:grpSpPr>
+        <a:xfrm>
+          <a:off x="0" y="0"/>
+          <a:ext cx="0" cy="0"/>
+          <a:chOff x="0" y="0"/>
+          <a:chExt cx="0" cy="0"/>
+        </a:xfrm>
+      </p:grpSpPr>
+      <p:sp>
+        <p:nvSpPr>
+          <p:cNvPr id="2" name="标题 1">
+            <a:extLst>
+              <a:ext uri="{FF2B5EF4-FFF2-40B4-BE49-F238E27FC236}">
+                <a16:creationId xmlns:a16="http://schemas.microsoft.com/office/drawing/2014/main" id="{B75EE23D-C64A-F9E5-3CF2-B885A531098D}"/>
+              </a:ext>
+            </a:extLst>
+          </p:cNvPr>
+          <p:cNvSpPr>
+            <a:spLocks noGrp="1"/>
+          </p:cNvSpPr>
+          <p:nvPr>
+            <p:ph type="title"/>
+          </p:nvPr>
+        </p:nvSpPr>
+        <p:spPr/>
+        <p:txBody>
+          <a:bodyPr/>
+          <a:lstStyle/>
+          <a:p>
+            <a:r>
+              <a:rPr lang="zh-CN" altLang="en-US" dirty="0"/>
+              <a:t>尝试重训</a:t>
+            </a:r>
+            <a:r>
+              <a:rPr lang="en-US" altLang="zh-CN" dirty="0"/>
+              <a:t>diffusion</a:t>
+            </a:r>
+            <a:r>
+              <a:rPr lang="zh-CN" altLang="en-US" dirty="0"/>
+              <a:t>，初步发现效果不大</a:t>
+            </a:r>
+          </a:p>
+        </p:txBody>
+      </p:sp>
+      <p:graphicFrame>
+        <p:nvGraphicFramePr>
+          <p:cNvPr id="4" name="内容占位符 3">
+            <a:extLst>
+              <a:ext uri="{FF2B5EF4-FFF2-40B4-BE49-F238E27FC236}">
+                <a16:creationId xmlns:a16="http://schemas.microsoft.com/office/drawing/2014/main" id="{F2241595-130A-BD17-DC86-D37FD3FC281B}"/>
+              </a:ext>
+            </a:extLst>
+          </p:cNvPr>
+          <p:cNvGraphicFramePr>
+            <a:graphicFrameLocks noGrp="1"/>
+          </p:cNvGraphicFramePr>
+          <p:nvPr>
+            <p:ph idx="1"/>
+            <p:extLst>
+              <p:ext uri="{D42A27DB-BD31-4B8C-83A1-F6EECF244321}">
+                <p14:modId xmlns:p14="http://schemas.microsoft.com/office/powerpoint/2010/main" val="3803873038"/>
+              </p:ext>
+            </p:extLst>
+          </p:nvPr>
+        </p:nvGraphicFramePr>
+        <p:xfrm>
+          <a:off x="778328" y="1410494"/>
+          <a:ext cx="10515600" cy="1828800"/>
+        </p:xfrm>
+        <a:graphic>
+          <a:graphicData uri="http://schemas.openxmlformats.org/drawingml/2006/table">
+            <a:tbl>
+              <a:tblPr>
+                <a:tableStyleId>{5C22544A-7EE6-4342-B048-85BDC9FD1C3A}</a:tableStyleId>
+              </a:tblPr>
+              <a:tblGrid>
+                <a:gridCol w="5257800">
+                  <a:extLst>
+                    <a:ext uri="{9D8B030D-6E8A-4147-A177-3AD203B41FA5}">
+                      <a16:colId xmlns:a16="http://schemas.microsoft.com/office/drawing/2014/main" val="2512115121"/>
+                    </a:ext>
+                  </a:extLst>
+                </a:gridCol>
+                <a:gridCol w="5257800">
+                  <a:extLst>
+                    <a:ext uri="{9D8B030D-6E8A-4147-A177-3AD203B41FA5}">
+                      <a16:colId xmlns:a16="http://schemas.microsoft.com/office/drawing/2014/main" val="2998032508"/>
+                    </a:ext>
+                  </a:extLst>
+                </a:gridCol>
+              </a:tblGrid>
+              <a:tr h="0">
+                <a:tc>
+                  <a:txBody>
+                    <a:bodyPr/>
+                    <a:lstStyle/>
+                    <a:p>
+                      <a:pPr>
+                        <a:buNone/>
+                      </a:pPr>
+                      <a:r>
+                        <a:rPr lang="zh-CN"/>
+                        <a:t>t*</a:t>
+                      </a:r>
+                    </a:p>
+                  </a:txBody>
+                  <a:tcPr anchor="ctr"/>
+                </a:tc>
+                <a:tc>
+                  <a:txBody>
+                    <a:bodyPr/>
+                    <a:lstStyle/>
+                    <a:p>
+                      <a:pPr>
+                        <a:buNone/>
+                      </a:pPr>
+                      <a:r>
+                        <a:rPr lang="zh-CN"/>
+                        <a:t>mAP50</a:t>
+                      </a:r>
+                    </a:p>
+                  </a:txBody>
+                  <a:tcPr anchor="ctr"/>
+                </a:tc>
+                <a:extLst>
+                  <a:ext uri="{0D108BD9-81ED-4DB2-BD59-A6C34878D82A}">
+                    <a16:rowId xmlns:a16="http://schemas.microsoft.com/office/drawing/2014/main" val="2776597269"/>
+                  </a:ext>
+                </a:extLst>
+              </a:tr>
+              <a:tr h="0">
+                <a:tc>
+                  <a:txBody>
+                    <a:bodyPr/>
+                    <a:lstStyle/>
+                    <a:p>
+                      <a:pPr>
+                        <a:buNone/>
+                      </a:pPr>
+                      <a:r>
+                        <a:rPr lang="zh-CN"/>
+                        <a:t>0，直接重建</a:t>
+                      </a:r>
+                    </a:p>
+                  </a:txBody>
+                  <a:tcPr anchor="ctr"/>
+                </a:tc>
+                <a:tc>
+                  <a:txBody>
+                    <a:bodyPr/>
+                    <a:lstStyle/>
+                    <a:p>
+                      <a:pPr>
+                        <a:buNone/>
+                      </a:pPr>
+                      <a:r>
+                        <a:rPr lang="zh-CN"/>
+                        <a:t>0.4021</a:t>
+                      </a:r>
+                    </a:p>
+                  </a:txBody>
+                  <a:tcPr anchor="ctr"/>
+                </a:tc>
+                <a:extLst>
+                  <a:ext uri="{0D108BD9-81ED-4DB2-BD59-A6C34878D82A}">
+                    <a16:rowId xmlns:a16="http://schemas.microsoft.com/office/drawing/2014/main" val="3876667728"/>
+                  </a:ext>
+                </a:extLst>
+              </a:tr>
+              <a:tr h="0">
+                <a:tc>
+                  <a:txBody>
+                    <a:bodyPr/>
+                    <a:lstStyle/>
+                    <a:p>
+                      <a:pPr>
+                        <a:buNone/>
+                      </a:pPr>
+                      <a:r>
+                        <a:rPr lang="zh-CN"/>
+                        <a:t>1</a:t>
+                      </a:r>
+                    </a:p>
+                  </a:txBody>
+                  <a:tcPr anchor="ctr"/>
+                </a:tc>
+                <a:tc>
+                  <a:txBody>
+                    <a:bodyPr/>
+                    <a:lstStyle/>
+                    <a:p>
+                      <a:pPr>
+                        <a:buNone/>
+                      </a:pPr>
+                      <a:r>
+                        <a:rPr lang="zh-CN"/>
+                        <a:t>0.4019</a:t>
+                      </a:r>
+                    </a:p>
+                  </a:txBody>
+                  <a:tcPr anchor="ctr"/>
+                </a:tc>
+                <a:extLst>
+                  <a:ext uri="{0D108BD9-81ED-4DB2-BD59-A6C34878D82A}">
+                    <a16:rowId xmlns:a16="http://schemas.microsoft.com/office/drawing/2014/main" val="3545540717"/>
+                  </a:ext>
+                </a:extLst>
+              </a:tr>
+              <a:tr h="0">
+                <a:tc>
+                  <a:txBody>
+                    <a:bodyPr/>
+                    <a:lstStyle/>
+                    <a:p>
+                      <a:pPr>
+                        <a:buNone/>
+                      </a:pPr>
+                      <a:r>
+                        <a:rPr lang="zh-CN"/>
+                        <a:t>2</a:t>
+                      </a:r>
+                    </a:p>
+                  </a:txBody>
+                  <a:tcPr anchor="ctr"/>
+                </a:tc>
+                <a:tc>
+                  <a:txBody>
+                    <a:bodyPr/>
+                    <a:lstStyle/>
+                    <a:p>
+                      <a:pPr>
+                        <a:buNone/>
+                      </a:pPr>
+                      <a:r>
+                        <a:rPr lang="zh-CN"/>
+                        <a:t>0.4019</a:t>
+                      </a:r>
+                    </a:p>
+                  </a:txBody>
+                  <a:tcPr anchor="ctr"/>
+                </a:tc>
+                <a:extLst>
+                  <a:ext uri="{0D108BD9-81ED-4DB2-BD59-A6C34878D82A}">
+                    <a16:rowId xmlns:a16="http://schemas.microsoft.com/office/drawing/2014/main" val="3065071712"/>
+                  </a:ext>
+                </a:extLst>
+              </a:tr>
+              <a:tr h="0">
+                <a:tc>
+                  <a:txBody>
+                    <a:bodyPr/>
+                    <a:lstStyle/>
+                    <a:p>
+                      <a:pPr>
+                        <a:buNone/>
+                      </a:pPr>
+                      <a:r>
+                        <a:rPr lang="zh-CN"/>
+                        <a:t>3</a:t>
+                      </a:r>
+                    </a:p>
+                  </a:txBody>
+                  <a:tcPr anchor="ctr"/>
+                </a:tc>
+                <a:tc>
+                  <a:txBody>
+                    <a:bodyPr/>
+                    <a:lstStyle/>
+                    <a:p>
+                      <a:pPr>
+                        <a:buNone/>
+                      </a:pPr>
+                      <a:r>
+                        <a:rPr lang="zh-CN" dirty="0"/>
+                        <a:t>0.4006</a:t>
+                      </a:r>
+                    </a:p>
+                  </a:txBody>
+                  <a:tcPr anchor="ctr"/>
+                </a:tc>
+                <a:extLst>
+                  <a:ext uri="{0D108BD9-81ED-4DB2-BD59-A6C34878D82A}">
+                    <a16:rowId xmlns:a16="http://schemas.microsoft.com/office/drawing/2014/main" val="2254871219"/>
+                  </a:ext>
+                </a:extLst>
+              </a:tr>
+            </a:tbl>
+          </a:graphicData>
+        </a:graphic>
+      </p:graphicFrame>
+      <p:sp>
+        <p:nvSpPr>
+          <p:cNvPr id="7" name="文本框 6">
+            <a:extLst>
+              <a:ext uri="{FF2B5EF4-FFF2-40B4-BE49-F238E27FC236}">
+                <a16:creationId xmlns:a16="http://schemas.microsoft.com/office/drawing/2014/main" id="{B6AD55C8-6B71-BFC2-E10E-9EDB91EF79A1}"/>
+              </a:ext>
+            </a:extLst>
+          </p:cNvPr>
+          <p:cNvSpPr txBox="1"/>
+          <p:nvPr/>
+        </p:nvSpPr>
+        <p:spPr>
+          <a:xfrm>
+            <a:off x="1066800" y="4213162"/>
+            <a:ext cx="6096000" cy="1477328"/>
+          </a:xfrm>
+          <a:prstGeom prst="rect">
+            <a:avLst/>
+          </a:prstGeom>
+          <a:noFill/>
+        </p:spPr>
+        <p:txBody>
+          <a:bodyPr wrap="square">
+            <a:spAutoFit/>
+          </a:bodyPr>
+          <a:lstStyle/>
+          <a:p>
+            <a:r>
+              <a:rPr lang="zh-CN" altLang="en-US" dirty="0"/>
+              <a:t>目前最佳方法是：</a:t>
+            </a:r>
+            <a:endParaRPr lang="en-US" altLang="zh-CN" dirty="0"/>
+          </a:p>
+          <a:p>
+            <a:r>
+              <a:rPr lang="zh-CN" altLang="en-US" dirty="0"/>
+              <a:t>PGD图像 → HF-AE直接重建mAP50 = 0.4021</a:t>
+            </a:r>
+            <a:endParaRPr lang="en-US" altLang="zh-CN" dirty="0"/>
+          </a:p>
+          <a:p>
+            <a:endParaRPr lang="en-US" altLang="zh-CN" dirty="0"/>
+          </a:p>
+          <a:p>
+            <a:r>
+              <a:rPr lang="zh-CN" altLang="zh-CN" dirty="0"/>
+              <a:t>如果还要发展 diffusion，必须改成针对训练集 PGD 配对编码、低 timestep 和少数变化 bit 加权的定向净化</a:t>
+            </a:r>
+            <a:endParaRPr lang="zh-CN" altLang="en-US" dirty="0"/>
+          </a:p>
+        </p:txBody>
+      </p:sp>
+    </p:spTree>
+    <p:extLst>
+      <p:ext uri="{BB962C8B-B14F-4D97-AF65-F5344CB8AC3E}">
+        <p14:creationId xmlns:p14="http://schemas.microsoft.com/office/powerpoint/2010/main" val="3587026271"/>
+      </p:ext>
+    </p:extLst>
+  </p:cSld>
+  <p:clrMapOvr>
+    <a:masterClrMapping/>
+  </p:clrMapOvr>
+</p:sld>
+</file>
+
 <file path=ppt/theme/theme1.xml><?xml version="1.0" encoding="utf-8"?>
 <a:theme xmlns:a="http://schemas.openxmlformats.org/drawingml/2006/main" name="Office 主题​​">
   <a:themeElements>

</xml_diff>